<commit_message>
Team program and author department set to CSE in report and deck
Co-Authored-By: Claude Fable 5.1 <noreply@anthropic.com>
</commit_message>
<xml_diff>
--- a/TERRARIUM-Presentation.pptx
+++ b/TERRARIUM-Presentation.pptx
@@ -2719,7 +2719,7 @@
                             <a:schemeClr val="tx1"/>
                           </a:solidFill>
                         </a:rPr>
-                        <a:t>BSc in EEE</a:t>
+                        <a:t>BSc in CSE</a:t>
                       </a:r>
                     </a:p>
                   </a:txBody>
@@ -2831,7 +2831,7 @@
                             <a:schemeClr val="tx1"/>
                           </a:solidFill>
                         </a:rPr>
-                        <a:t>BSc in EEE</a:t>
+                        <a:t>BSc in CSE</a:t>
                       </a:r>
                     </a:p>
                   </a:txBody>
@@ -2953,7 +2953,7 @@
                             <a:schemeClr val="tx1"/>
                           </a:solidFill>
                         </a:rPr>
-                        <a:t>BSc in EEE</a:t>
+                        <a:t>BSc in CSE</a:t>
                       </a:r>
                       <a:endParaRPr lang="en-US" sz="2400" i="1" dirty="0">
                         <a:solidFill>
@@ -3077,7 +3077,7 @@
                             <a:schemeClr val="tx1"/>
                           </a:solidFill>
                         </a:rPr>
-                        <a:t>BSc in EEE</a:t>
+                        <a:t>BSc in CSE</a:t>
                       </a:r>
                       <a:endParaRPr lang="en-US" sz="2400" i="1" dirty="0">
                         <a:solidFill>

</xml_diff>

<commit_message>
Detailed report: six-member team, prototype photo, architecture and control-flow figures, pin map, parameter and protocol tables, test matrix, survey appendix; deck gets 6th member and prototype photo
Co-Authored-By: Claude Fable 5.1 <noreply@anthropic.com>
</commit_message>
<xml_diff>
--- a/TERRARIUM-Presentation.pptx
+++ b/TERRARIUM-Presentation.pptx
@@ -2422,7 +2422,7 @@
         </p:nvGraphicFramePr>
         <p:xfrm>
           <a:off x="659786" y="4996918"/>
-          <a:ext cx="15359148" cy="2743200"/>
+          <a:ext cx="15359148" cy="2443083"/>
         </p:xfrm>
         <a:graphic>
           <a:graphicData uri="http://schemas.openxmlformats.org/drawingml/2006/table">
@@ -2652,7 +2652,7 @@
                   </a:ext>
                 </a:extLst>
               </a:tr>
-              <a:tr h="370840">
+              <a:tr h="347472">
                 <a:tc>
                   <a:txBody>
                     <a:bodyPr/>
@@ -2764,7 +2764,7 @@
                   </a:ext>
                 </a:extLst>
               </a:tr>
-              <a:tr h="370840">
+              <a:tr h="347472">
                 <a:tc>
                   <a:txBody>
                     <a:bodyPr/>
@@ -2795,7 +2795,7 @@
                             <a:schemeClr val="tx1"/>
                           </a:solidFill>
                         </a:rPr>
-                        <a:t>23-55027-3</a:t>
+                        <a:t>23-54483-3</a:t>
                       </a:r>
                     </a:p>
                   </a:txBody>
@@ -2813,7 +2813,7 @@
                             <a:schemeClr val="tx1"/>
                           </a:solidFill>
                         </a:rPr>
-                        <a:t>Tahomina Era</a:t>
+                        <a:t>MD. Shakhawat Hossen</a:t>
                       </a:r>
                     </a:p>
                   </a:txBody>
@@ -2876,7 +2876,7 @@
                   </a:ext>
                 </a:extLst>
               </a:tr>
-              <a:tr h="370840">
+              <a:tr h="347472">
                 <a:tc>
                   <a:txBody>
                     <a:bodyPr/>
@@ -2907,7 +2907,7 @@
                             <a:schemeClr val="tx1"/>
                           </a:solidFill>
                         </a:rPr>
-                        <a:t>23-54483-3</a:t>
+                        <a:t>23-55027-3</a:t>
                       </a:r>
                       <a:endParaRPr lang="en-US" sz="2400" i="1" dirty="0">
                         <a:solidFill>
@@ -2930,7 +2930,7 @@
                             <a:schemeClr val="tx1"/>
                           </a:solidFill>
                         </a:rPr>
-                        <a:t>MD. Shakhawat Hossen</a:t>
+                        <a:t>Tahomina Era</a:t>
                       </a:r>
                       <a:endParaRPr lang="en-US" sz="2400" i="1" dirty="0">
                         <a:solidFill>
@@ -3000,7 +3000,7 @@
                   </a:ext>
                 </a:extLst>
               </a:tr>
-              <a:tr h="370840">
+              <a:tr h="347472">
                 <a:tc>
                   <a:txBody>
                     <a:bodyPr/>
@@ -3124,7 +3124,7 @@
                   </a:ext>
                 </a:extLst>
               </a:tr>
-              <a:tr h="370840">
+              <a:tr h="347472">
                 <a:tc>
                   <a:txBody>
                     <a:bodyPr/>
@@ -3139,6 +3139,75 @@
                         </a:rPr>
                         <a:t>5</a:t>
                       </a:r>
+                    </a:p>
+                  </a:txBody>
+                  <a:tcPr anchor="ctr"/>
+                </a:tc>
+                <a:tc>
+                  <a:txBody>
+                    <a:bodyPr/>
+                    <a:lstStyle/>
+                    <a:p>
+                      <a:pPr algn="ctr"/>
+                      <a:r>
+                        <a:rPr lang="en-US" sz="2400" i="1" dirty="0">
+                          <a:solidFill>
+                            <a:schemeClr val="tx1"/>
+                          </a:solidFill>
+                        </a:rPr>
+                        <a:t>23-54545-3</a:t>
+                      </a:r>
+                      <a:endParaRPr lang="en-US" sz="2400" i="1" dirty="0">
+                        <a:solidFill>
+                          <a:schemeClr val="tx1"/>
+                        </a:solidFill>
+                      </a:endParaRPr>
+                    </a:p>
+                  </a:txBody>
+                  <a:tcPr anchor="ctr"/>
+                </a:tc>
+                <a:tc>
+                  <a:txBody>
+                    <a:bodyPr/>
+                    <a:lstStyle/>
+                    <a:p>
+                      <a:pPr algn="ctr"/>
+                      <a:r>
+                        <a:rPr lang="en-US" sz="2400" i="1" dirty="0">
+                          <a:solidFill>
+                            <a:schemeClr val="tx1"/>
+                          </a:solidFill>
+                        </a:rPr>
+                        <a:t>Jannatun Nur Deba</a:t>
+                      </a:r>
+                      <a:endParaRPr lang="en-US" sz="2400" i="1" dirty="0">
+                        <a:solidFill>
+                          <a:schemeClr val="tx1"/>
+                        </a:solidFill>
+                      </a:endParaRPr>
+                    </a:p>
+                  </a:txBody>
+                  <a:tcPr anchor="ctr"/>
+                </a:tc>
+                <a:tc>
+                  <a:txBody>
+                    <a:bodyPr/>
+                    <a:lstStyle/>
+                    <a:p>
+                      <a:pPr algn="ctr"/>
+                      <a:r>
+                        <a:rPr lang="en-US" sz="2400" i="1" dirty="0">
+                          <a:solidFill>
+                            <a:schemeClr val="tx1"/>
+                          </a:solidFill>
+                        </a:rPr>
+                        <a:t>BSc in CSE</a:t>
+                      </a:r>
+                      <a:endParaRPr lang="en-US" sz="2400" i="1" dirty="0">
+                        <a:solidFill>
+                          <a:schemeClr val="tx1"/>
+                        </a:solidFill>
+                      </a:endParaRPr>
                     </a:p>
                   </a:txBody>
                   <a:tcPr anchor="ctr"/>
@@ -3173,12 +3242,91 @@
                   </a:txBody>
                   <a:tcPr anchor="ctr"/>
                 </a:tc>
+                <a:extLst>
+                  <a:ext uri="{0D108BD9-81ED-4DB2-BD59-A6C34878D82A}">
+                    <a16:rowId xmlns:a16="http://schemas.microsoft.com/office/drawing/2014/main" val="901570957"/>
+                  </a:ext>
+                </a:extLst>
+              </a:tr>
+              <a:tr h="347472">
                 <a:tc>
                   <a:txBody>
                     <a:bodyPr/>
                     <a:lstStyle/>
                     <a:p>
                       <a:pPr algn="ctr"/>
+                      <a:r>
+                        <a:rPr lang="en-US" sz="2400" i="1" dirty="0">
+                          <a:solidFill>
+                            <a:schemeClr val="tx1"/>
+                          </a:solidFill>
+                        </a:rPr>
+                        <a:t>6</a:t>
+                      </a:r>
+                    </a:p>
+                  </a:txBody>
+                  <a:tcPr anchor="ctr"/>
+                </a:tc>
+                <a:tc>
+                  <a:txBody>
+                    <a:bodyPr/>
+                    <a:lstStyle/>
+                    <a:p>
+                      <a:pPr algn="ctr"/>
+                      <a:r>
+                        <a:rPr lang="en-US" sz="2400" i="1" dirty="0">
+                          <a:solidFill>
+                            <a:schemeClr val="tx1"/>
+                          </a:solidFill>
+                        </a:rPr>
+                        <a:t>23-55557-3</a:t>
+                      </a:r>
+                      <a:endParaRPr lang="en-US" sz="2400" i="1" dirty="0">
+                        <a:solidFill>
+                          <a:schemeClr val="tx1"/>
+                        </a:solidFill>
+                      </a:endParaRPr>
+                    </a:p>
+                  </a:txBody>
+                  <a:tcPr anchor="ctr"/>
+                </a:tc>
+                <a:tc>
+                  <a:txBody>
+                    <a:bodyPr/>
+                    <a:lstStyle/>
+                    <a:p>
+                      <a:pPr algn="ctr"/>
+                      <a:r>
+                        <a:rPr lang="en-US" sz="2400" i="1" dirty="0">
+                          <a:solidFill>
+                            <a:schemeClr val="tx1"/>
+                          </a:solidFill>
+                        </a:rPr>
+                        <a:t>MD. Alfaz Uddin</a:t>
+                      </a:r>
+                      <a:endParaRPr lang="en-US" sz="2400" i="1" dirty="0">
+                        <a:solidFill>
+                          <a:schemeClr val="tx1"/>
+                        </a:solidFill>
+                      </a:endParaRPr>
+                    </a:p>
+                  </a:txBody>
+                  <a:tcPr anchor="ctr"/>
+                </a:tc>
+                <a:tc>
+                  <a:txBody>
+                    <a:bodyPr/>
+                    <a:lstStyle/>
+                    <a:p>
+                      <a:pPr algn="ctr"/>
+                      <a:r>
+                        <a:rPr lang="en-US" sz="2400" i="1" dirty="0">
+                          <a:solidFill>
+                            <a:schemeClr val="tx1"/>
+                          </a:solidFill>
+                        </a:rPr>
+                        <a:t>BSc in CSE</a:t>
+                      </a:r>
                       <a:endParaRPr lang="en-US" sz="2400" i="1" dirty="0">
                         <a:solidFill>
                           <a:schemeClr val="tx1"/>
@@ -10266,6 +10414,64 @@
               <a:t>7</a:t>
             </a:fld>
             <a:endParaRPr lang="en-US" dirty="0"/>
+          </a:p>
+        </p:txBody>
+      </p:sp>
+      <p:pic>
+        <p:nvPicPr>
+          <p:cNvPr id="17412" name="Picture 17411" descr="prototype-photo.jpg"/>
+          <p:cNvPicPr>
+            <a:picLocks noChangeAspect="1"/>
+          </p:cNvPicPr>
+          <p:nvPr/>
+        </p:nvPicPr>
+        <p:blipFill>
+          <a:blip r:embed="rId3"/>
+          <a:stretch>
+            <a:fillRect/>
+          </a:stretch>
+        </p:blipFill>
+        <p:spPr>
+          <a:xfrm>
+            <a:off x="7059168" y="4526280"/>
+            <a:ext cx="2331720" cy="3108960"/>
+          </a:xfrm>
+          <a:prstGeom prst="rect">
+            <a:avLst/>
+          </a:prstGeom>
+        </p:spPr>
+      </p:pic>
+      <p:sp>
+        <p:nvSpPr>
+          <p:cNvPr id="17413" name="TextBox 17412"/>
+          <p:cNvSpPr txBox="1"/>
+          <p:nvPr/>
+        </p:nvSpPr>
+        <p:spPr>
+          <a:xfrm>
+            <a:off x="4572000" y="7662672"/>
+            <a:ext cx="7315200" cy="320040"/>
+          </a:xfrm>
+          <a:prstGeom prst="rect">
+            <a:avLst/>
+          </a:prstGeom>
+          <a:noFill/>
+        </p:spPr>
+        <p:txBody>
+          <a:bodyPr wrap="none">
+            <a:spAutoFit/>
+          </a:bodyPr>
+          <a:lstStyle/>
+          <a:p>
+            <a:pPr algn="ctr"/>
+            <a:r>
+              <a:rPr sz="1300" i="1">
+                <a:solidFill>
+                  <a:srgbClr val="444444"/>
+                </a:solidFill>
+              </a:rPr>
+              <a:t>Fig. 8: Working prototype with a live Fittonia plant under automatic control</a:t>
+            </a:r>
           </a:p>
         </p:txBody>
       </p:sp>

</xml_diff>